<commit_message>
Write the spoken pitch into the deck's speaker notes
A deck read aloud from its own bullet points is the commonest way a good
product pitches badly, so the words are in the notes and the slides stay
pictures. Two to four sentences a slide, twenty to thirty seconds each, about
eight minutes for the full run — in Uzbek and English, matched to each file.

Eight slides are marked as a three-minute cut: cover, problem, the answered
problems, what makes it not an ordinary NFC card, market size, the arithmetic,
the one real photograph, and the ask. Skipping the rest still carries problem,
mechanism, difference, proof, market and ask, which is what a screening round
asks for.

The notes say the things a slide cannot: that the eight problems came from
customers rather than from us, that nothing on the answer slide is future work,
that the photograph on the status slide is the only one in the deck that is not
a render.

Co-Authored-By: Claude Opus 5 <noreply@anthropic.com>
</commit_message>
<xml_diff>
--- a/deck/flex-pitch-en.pptx
+++ b/deck/flex-pitch-en.pptx
@@ -124,6 +124,1876 @@
     </a:lvl9pPr>
   </p:defaultTextStyle>
 </p:presentation>
+</file>
+
+<file path=ppt/notesMasters/notesMaster1.xml><?xml version="1.0" encoding="utf-8"?>
+<p:notesMaster xmlns:a="http://schemas.openxmlformats.org/drawingml/2006/main" xmlns:p="http://schemas.openxmlformats.org/presentationml/2006/main" xmlns:r="http://schemas.openxmlformats.org/officeDocument/2006/relationships">
+  <p:cSld>
+    <p:bg>
+      <p:bgRef idx="1001">
+        <a:schemeClr val="bg1"/>
+      </p:bgRef>
+    </p:bg>
+    <p:spTree>
+      <p:nvGrpSpPr>
+        <p:cNvPr id="1" name=""/>
+        <p:cNvGrpSpPr/>
+        <p:nvPr/>
+      </p:nvGrpSpPr>
+      <p:grpSpPr>
+        <a:xfrm>
+          <a:off x="0" y="0"/>
+          <a:ext cx="0" cy="0"/>
+          <a:chOff x="0" y="0"/>
+          <a:chExt cx="0" cy="0"/>
+        </a:xfrm>
+      </p:grpSpPr>
+      <p:sp>
+        <p:nvSpPr>
+          <p:cNvPr id="2" name="Header Placeholder 1"/>
+          <p:cNvSpPr>
+            <a:spLocks noGrp="1"/>
+          </p:cNvSpPr>
+          <p:nvPr>
+            <p:ph type="hdr" sz="quarter"/>
+          </p:nvPr>
+        </p:nvSpPr>
+        <p:spPr>
+          <a:xfrm>
+            <a:off x="0" y="0"/>
+            <a:ext cx="2971800" cy="457200"/>
+          </a:xfrm>
+          <a:prstGeom prst="rect">
+            <a:avLst/>
+          </a:prstGeom>
+        </p:spPr>
+        <p:txBody>
+          <a:bodyPr vert="horz" lIns="91440" tIns="45720" rIns="91440" bIns="45720" rtlCol="0"/>
+          <a:lstStyle>
+            <a:lvl1pPr algn="l">
+              <a:defRPr sz="1200"/>
+            </a:lvl1pPr>
+          </a:lstStyle>
+          <a:p>
+            <a:endParaRPr lang="en-US"/>
+          </a:p>
+        </p:txBody>
+      </p:sp>
+      <p:sp>
+        <p:nvSpPr>
+          <p:cNvPr id="3" name="Date Placeholder 2"/>
+          <p:cNvSpPr>
+            <a:spLocks noGrp="1"/>
+          </p:cNvSpPr>
+          <p:nvPr>
+            <p:ph type="dt" idx="1"/>
+          </p:nvPr>
+        </p:nvSpPr>
+        <p:spPr>
+          <a:xfrm>
+            <a:off x="3884613" y="0"/>
+            <a:ext cx="2971800" cy="457200"/>
+          </a:xfrm>
+          <a:prstGeom prst="rect">
+            <a:avLst/>
+          </a:prstGeom>
+        </p:spPr>
+        <p:txBody>
+          <a:bodyPr vert="horz" lIns="91440" tIns="45720" rIns="91440" bIns="45720" rtlCol="0"/>
+          <a:lstStyle>
+            <a:lvl1pPr algn="r">
+              <a:defRPr sz="1200"/>
+            </a:lvl1pPr>
+          </a:lstStyle>
+          <a:p>
+            <a:fld id="{0F89C1C7-3DCD-1040-A9CF-14679D8B5DDD}" type="datetimeFigureOut">
+              <a:rPr lang="en-US" smtClean="0"/>
+              <a:t>10/17/16</a:t>
+            </a:fld>
+            <a:endParaRPr lang="en-US"/>
+          </a:p>
+        </p:txBody>
+      </p:sp>
+      <p:sp>
+        <p:nvSpPr>
+          <p:cNvPr id="4" name="Slide Image Placeholder 3"/>
+          <p:cNvSpPr>
+            <a:spLocks noGrp="1" noRot="1" noChangeAspect="1"/>
+          </p:cNvSpPr>
+          <p:nvPr>
+            <p:ph type="sldImg" idx="2"/>
+          </p:nvPr>
+        </p:nvSpPr>
+        <p:spPr>
+          <a:xfrm>
+            <a:off x="1143000" y="685800"/>
+            <a:ext cx="4572000" cy="3429000"/>
+          </a:xfrm>
+          <a:prstGeom prst="rect">
+            <a:avLst/>
+          </a:prstGeom>
+          <a:noFill/>
+          <a:ln w="12700">
+            <a:solidFill>
+              <a:prstClr val="black"/>
+            </a:solidFill>
+          </a:ln>
+        </p:spPr>
+        <p:txBody>
+          <a:bodyPr vert="horz" lIns="91440" tIns="45720" rIns="91440" bIns="45720" rtlCol="0" anchor="ctr"/>
+          <a:lstStyle/>
+          <a:p>
+            <a:endParaRPr lang="en-US"/>
+          </a:p>
+        </p:txBody>
+      </p:sp>
+      <p:sp>
+        <p:nvSpPr>
+          <p:cNvPr id="5" name="Notes Placeholder 4"/>
+          <p:cNvSpPr>
+            <a:spLocks noGrp="1"/>
+          </p:cNvSpPr>
+          <p:nvPr>
+            <p:ph type="body" sz="quarter" idx="3"/>
+          </p:nvPr>
+        </p:nvSpPr>
+        <p:spPr>
+          <a:xfrm>
+            <a:off x="685800" y="4343400"/>
+            <a:ext cx="5486400" cy="4114800"/>
+          </a:xfrm>
+          <a:prstGeom prst="rect">
+            <a:avLst/>
+          </a:prstGeom>
+        </p:spPr>
+        <p:txBody>
+          <a:bodyPr vert="horz" lIns="91440" tIns="45720" rIns="91440" bIns="45720" rtlCol="0"/>
+          <a:lstStyle/>
+          <a:p>
+            <a:pPr lvl="0"/>
+            <a:r>
+              <a:rPr lang="en-US" smtClean="0"/>
+              <a:t>Click to edit Master text styles</a:t>
+            </a:r>
+          </a:p>
+          <a:p>
+            <a:pPr lvl="1"/>
+            <a:r>
+              <a:rPr lang="en-US" smtClean="0"/>
+              <a:t>Second level</a:t>
+            </a:r>
+          </a:p>
+          <a:p>
+            <a:pPr lvl="2"/>
+            <a:r>
+              <a:rPr lang="en-US" smtClean="0"/>
+              <a:t>Third level</a:t>
+            </a:r>
+          </a:p>
+          <a:p>
+            <a:pPr lvl="3"/>
+            <a:r>
+              <a:rPr lang="en-US" smtClean="0"/>
+              <a:t>Fourth level</a:t>
+            </a:r>
+          </a:p>
+          <a:p>
+            <a:pPr lvl="4"/>
+            <a:r>
+              <a:rPr lang="en-US" smtClean="0"/>
+              <a:t>Fifth level</a:t>
+            </a:r>
+            <a:endParaRPr lang="en-US"/>
+          </a:p>
+        </p:txBody>
+      </p:sp>
+      <p:sp>
+        <p:nvSpPr>
+          <p:cNvPr id="6" name="Footer Placeholder 5"/>
+          <p:cNvSpPr>
+            <a:spLocks noGrp="1"/>
+          </p:cNvSpPr>
+          <p:nvPr>
+            <p:ph type="ftr" sz="quarter" idx="4"/>
+          </p:nvPr>
+        </p:nvSpPr>
+        <p:spPr>
+          <a:xfrm>
+            <a:off x="0" y="8685213"/>
+            <a:ext cx="2971800" cy="457200"/>
+          </a:xfrm>
+          <a:prstGeom prst="rect">
+            <a:avLst/>
+          </a:prstGeom>
+        </p:spPr>
+        <p:txBody>
+          <a:bodyPr vert="horz" lIns="91440" tIns="45720" rIns="91440" bIns="45720" rtlCol="0" anchor="b"/>
+          <a:lstStyle>
+            <a:lvl1pPr algn="l">
+              <a:defRPr sz="1200"/>
+            </a:lvl1pPr>
+          </a:lstStyle>
+          <a:p>
+            <a:endParaRPr lang="en-US"/>
+          </a:p>
+        </p:txBody>
+      </p:sp>
+      <p:sp>
+        <p:nvSpPr>
+          <p:cNvPr id="7" name="Slide Number Placeholder 6"/>
+          <p:cNvSpPr>
+            <a:spLocks noGrp="1"/>
+          </p:cNvSpPr>
+          <p:nvPr>
+            <p:ph type="sldNum" sz="quarter" idx="5"/>
+          </p:nvPr>
+        </p:nvSpPr>
+        <p:spPr>
+          <a:xfrm>
+            <a:off x="3884613" y="8685213"/>
+            <a:ext cx="2971800" cy="457200"/>
+          </a:xfrm>
+          <a:prstGeom prst="rect">
+            <a:avLst/>
+          </a:prstGeom>
+        </p:spPr>
+        <p:txBody>
+          <a:bodyPr vert="horz" lIns="91440" tIns="45720" rIns="91440" bIns="45720" rtlCol="0" anchor="b"/>
+          <a:lstStyle>
+            <a:lvl1pPr algn="r">
+              <a:defRPr sz="1200"/>
+            </a:lvl1pPr>
+          </a:lstStyle>
+          <a:p>
+            <a:fld id="{BB5E49A5-4136-284D-997B-48E1D791AD67}" type="slidenum">
+              <a:rPr lang="en-US" smtClean="0"/>
+              <a:t>‹#›</a:t>
+            </a:fld>
+            <a:endParaRPr lang="en-US"/>
+          </a:p>
+        </p:txBody>
+      </p:sp>
+    </p:spTree>
+    <p:extLst>
+      <p:ext uri="{BB962C8B-B14F-4D97-AF65-F5344CB8AC3E}">
+        <p14:creationId xmlns:p14="http://schemas.microsoft.com/office/powerpoint/2010/main" val="2623252185"/>
+      </p:ext>
+    </p:extLst>
+  </p:cSld>
+  <p:clrMap bg1="lt1" tx1="dk1" bg2="lt2" tx2="dk2" accent1="accent1" accent2="accent2" accent3="accent3" accent4="accent4" accent5="accent5" accent6="accent6" hlink="hlink" folHlink="folHlink"/>
+  <p:notesStyle>
+    <a:lvl1pPr marL="0" algn="l" defTabSz="457200" rtl="0" eaLnBrk="1" latinLnBrk="0" hangingPunct="1">
+      <a:defRPr sz="1200" kern="1200">
+        <a:solidFill>
+          <a:schemeClr val="tx1"/>
+        </a:solidFill>
+        <a:latin typeface="+mn-lt"/>
+        <a:ea typeface="+mn-ea"/>
+        <a:cs typeface="+mn-cs"/>
+      </a:defRPr>
+    </a:lvl1pPr>
+    <a:lvl2pPr marL="457200" algn="l" defTabSz="457200" rtl="0" eaLnBrk="1" latinLnBrk="0" hangingPunct="1">
+      <a:defRPr sz="1200" kern="1200">
+        <a:solidFill>
+          <a:schemeClr val="tx1"/>
+        </a:solidFill>
+        <a:latin typeface="+mn-lt"/>
+        <a:ea typeface="+mn-ea"/>
+        <a:cs typeface="+mn-cs"/>
+      </a:defRPr>
+    </a:lvl2pPr>
+    <a:lvl3pPr marL="914400" algn="l" defTabSz="457200" rtl="0" eaLnBrk="1" latinLnBrk="0" hangingPunct="1">
+      <a:defRPr sz="1200" kern="1200">
+        <a:solidFill>
+          <a:schemeClr val="tx1"/>
+        </a:solidFill>
+        <a:latin typeface="+mn-lt"/>
+        <a:ea typeface="+mn-ea"/>
+        <a:cs typeface="+mn-cs"/>
+      </a:defRPr>
+    </a:lvl3pPr>
+    <a:lvl4pPr marL="1371600" algn="l" defTabSz="457200" rtl="0" eaLnBrk="1" latinLnBrk="0" hangingPunct="1">
+      <a:defRPr sz="1200" kern="1200">
+        <a:solidFill>
+          <a:schemeClr val="tx1"/>
+        </a:solidFill>
+        <a:latin typeface="+mn-lt"/>
+        <a:ea typeface="+mn-ea"/>
+        <a:cs typeface="+mn-cs"/>
+      </a:defRPr>
+    </a:lvl4pPr>
+    <a:lvl5pPr marL="1828800" algn="l" defTabSz="457200" rtl="0" eaLnBrk="1" latinLnBrk="0" hangingPunct="1">
+      <a:defRPr sz="1200" kern="1200">
+        <a:solidFill>
+          <a:schemeClr val="tx1"/>
+        </a:solidFill>
+        <a:latin typeface="+mn-lt"/>
+        <a:ea typeface="+mn-ea"/>
+        <a:cs typeface="+mn-cs"/>
+      </a:defRPr>
+    </a:lvl5pPr>
+    <a:lvl6pPr marL="2286000" algn="l" defTabSz="457200" rtl="0" eaLnBrk="1" latinLnBrk="0" hangingPunct="1">
+      <a:defRPr sz="1200" kern="1200">
+        <a:solidFill>
+          <a:schemeClr val="tx1"/>
+        </a:solidFill>
+        <a:latin typeface="+mn-lt"/>
+        <a:ea typeface="+mn-ea"/>
+        <a:cs typeface="+mn-cs"/>
+      </a:defRPr>
+    </a:lvl6pPr>
+    <a:lvl7pPr marL="2743200" algn="l" defTabSz="457200" rtl="0" eaLnBrk="1" latinLnBrk="0" hangingPunct="1">
+      <a:defRPr sz="1200" kern="1200">
+        <a:solidFill>
+          <a:schemeClr val="tx1"/>
+        </a:solidFill>
+        <a:latin typeface="+mn-lt"/>
+        <a:ea typeface="+mn-ea"/>
+        <a:cs typeface="+mn-cs"/>
+      </a:defRPr>
+    </a:lvl7pPr>
+    <a:lvl8pPr marL="3200400" algn="l" defTabSz="457200" rtl="0" eaLnBrk="1" latinLnBrk="0" hangingPunct="1">
+      <a:defRPr sz="1200" kern="1200">
+        <a:solidFill>
+          <a:schemeClr val="tx1"/>
+        </a:solidFill>
+        <a:latin typeface="+mn-lt"/>
+        <a:ea typeface="+mn-ea"/>
+        <a:cs typeface="+mn-cs"/>
+      </a:defRPr>
+    </a:lvl8pPr>
+    <a:lvl9pPr marL="3657600" algn="l" defTabSz="457200" rtl="0" eaLnBrk="1" latinLnBrk="0" hangingPunct="1">
+      <a:defRPr sz="1200" kern="1200">
+        <a:solidFill>
+          <a:schemeClr val="tx1"/>
+        </a:solidFill>
+        <a:latin typeface="+mn-lt"/>
+        <a:ea typeface="+mn-ea"/>
+        <a:cs typeface="+mn-cs"/>
+      </a:defRPr>
+    </a:lvl9pPr>
+  </p:notesStyle>
+</p:notesMaster>
+</file>
+
+<file path=ppt/notesSlides/notesSlide1.xml><?xml version="1.0" encoding="utf-8"?>
+<p:notes xmlns:a="http://schemas.openxmlformats.org/drawingml/2006/main" xmlns:p="http://schemas.openxmlformats.org/presentationml/2006/main" xmlns:r="http://schemas.openxmlformats.org/officeDocument/2006/relationships">
+  <p:cSld>
+    <p:spTree>
+      <p:nvGrpSpPr>
+        <p:cNvPr id="1" name=""/>
+        <p:cNvGrpSpPr/>
+        <p:nvPr/>
+      </p:nvGrpSpPr>
+      <p:grpSpPr>
+        <a:xfrm>
+          <a:off x="0" y="0"/>
+          <a:ext cx="0" cy="0"/>
+          <a:chOff x="0" y="0"/>
+          <a:chExt cx="0" cy="0"/>
+        </a:xfrm>
+      </p:grpSpPr>
+      <p:sp>
+        <p:nvSpPr>
+          <p:cNvPr id="2" name="Slide Image Placeholder 1"/>
+          <p:cNvSpPr>
+            <a:spLocks noGrp="1"/>
+          </p:cNvSpPr>
+          <p:nvPr>
+            <p:ph type="sldImg" idx="2"/>
+          </p:nvPr>
+        </p:nvSpPr>
+        <p:spPr/>
+      </p:sp>
+      <p:sp>
+        <p:nvSpPr>
+          <p:cNvPr id="3" name="Notes Placeholder 2"/>
+          <p:cNvSpPr>
+            <a:spLocks noGrp="1"/>
+          </p:cNvSpPr>
+          <p:nvPr>
+            <p:ph type="body" idx="3" sz="quarter"/>
+          </p:nvPr>
+        </p:nvSpPr>
+        <p:spPr/>
+        <p:txBody>
+          <a:bodyPr/>
+          <a:lstStyle/>
+          <a:p>
+            <a:r>
+              <a:t>1/20  ·  [3-MINUTE CUT]</a:t>
+            </a:r>
+          </a:p>
+          <a:p/>
+          <a:p>
+            <a:r>
+              <a:t>Good afternoon. I am Javohir, founder of FLEX. We give a person or a business a permanent unique number, and we sell the NFC object that opens it. In three minutes I will tell you what we are building and why it works.</a:t>
+            </a:r>
+          </a:p>
+        </p:txBody>
+      </p:sp>
+      <p:sp>
+        <p:nvSpPr>
+          <p:cNvPr id="4" name="Slide Number Placeholder 3"/>
+          <p:cNvSpPr>
+            <a:spLocks noGrp="1"/>
+          </p:cNvSpPr>
+          <p:nvPr>
+            <p:ph type="sldNum" idx="5" sz="quarter"/>
+          </p:nvPr>
+        </p:nvSpPr>
+        <p:spPr/>
+      </p:sp>
+    </p:spTree>
+  </p:cSld>
+  <p:clrMapOvr>
+    <a:masterClrMapping/>
+  </p:clrMapOvr>
+</p:notes>
+</file>
+
+<file path=ppt/notesSlides/notesSlide10.xml><?xml version="1.0" encoding="utf-8"?>
+<p:notes xmlns:a="http://schemas.openxmlformats.org/drawingml/2006/main" xmlns:p="http://schemas.openxmlformats.org/presentationml/2006/main" xmlns:r="http://schemas.openxmlformats.org/officeDocument/2006/relationships">
+  <p:cSld>
+    <p:spTree>
+      <p:nvGrpSpPr>
+        <p:cNvPr id="1" name=""/>
+        <p:cNvGrpSpPr/>
+        <p:nvPr/>
+      </p:nvGrpSpPr>
+      <p:grpSpPr>
+        <a:xfrm>
+          <a:off x="0" y="0"/>
+          <a:ext cx="0" cy="0"/>
+          <a:chOff x="0" y="0"/>
+          <a:chExt cx="0" cy="0"/>
+        </a:xfrm>
+      </p:grpSpPr>
+      <p:sp>
+        <p:nvSpPr>
+          <p:cNvPr id="2" name="Slide Image Placeholder 1"/>
+          <p:cNvSpPr>
+            <a:spLocks noGrp="1"/>
+          </p:cNvSpPr>
+          <p:nvPr>
+            <p:ph type="sldImg" idx="2"/>
+          </p:nvPr>
+        </p:nvSpPr>
+        <p:spPr/>
+      </p:sp>
+      <p:sp>
+        <p:nvSpPr>
+          <p:cNvPr id="3" name="Notes Placeholder 2"/>
+          <p:cNvSpPr>
+            <a:spLocks noGrp="1"/>
+          </p:cNvSpPr>
+          <p:nvPr>
+            <p:ph type="body" idx="3" sz="quarter"/>
+          </p:nvPr>
+        </p:nvSpPr>
+        <p:spPr/>
+        <p:txBody>
+          <a:bodyPr/>
+          <a:lstStyle/>
+          <a:p>
+            <a:r>
+              <a:t>10/20</a:t>
+            </a:r>
+          </a:p>
+          <a:p/>
+          <a:p>
+            <a:r>
+              <a:t>Look at the row that matters: the venue half. UNQX sells a personal card and stops there. Popl and V1CE are international, but there is no Uzbek and no invoice. Nobody local sells the venue side. They sell once; we get paid every month.</a:t>
+            </a:r>
+          </a:p>
+        </p:txBody>
+      </p:sp>
+      <p:sp>
+        <p:nvSpPr>
+          <p:cNvPr id="4" name="Slide Number Placeholder 3"/>
+          <p:cNvSpPr>
+            <a:spLocks noGrp="1"/>
+          </p:cNvSpPr>
+          <p:nvPr>
+            <p:ph type="sldNum" idx="5" sz="quarter"/>
+          </p:nvPr>
+        </p:nvSpPr>
+        <p:spPr/>
+      </p:sp>
+    </p:spTree>
+  </p:cSld>
+  <p:clrMapOvr>
+    <a:masterClrMapping/>
+  </p:clrMapOvr>
+</p:notes>
+</file>
+
+<file path=ppt/notesSlides/notesSlide11.xml><?xml version="1.0" encoding="utf-8"?>
+<p:notes xmlns:a="http://schemas.openxmlformats.org/drawingml/2006/main" xmlns:p="http://schemas.openxmlformats.org/presentationml/2006/main" xmlns:r="http://schemas.openxmlformats.org/officeDocument/2006/relationships">
+  <p:cSld>
+    <p:spTree>
+      <p:nvGrpSpPr>
+        <p:cNvPr id="1" name=""/>
+        <p:cNvGrpSpPr/>
+        <p:nvPr/>
+      </p:nvGrpSpPr>
+      <p:grpSpPr>
+        <a:xfrm>
+          <a:off x="0" y="0"/>
+          <a:ext cx="0" cy="0"/>
+          <a:chOff x="0" y="0"/>
+          <a:chExt cx="0" cy="0"/>
+        </a:xfrm>
+      </p:grpSpPr>
+      <p:sp>
+        <p:nvSpPr>
+          <p:cNvPr id="2" name="Slide Image Placeholder 1"/>
+          <p:cNvSpPr>
+            <a:spLocks noGrp="1"/>
+          </p:cNvSpPr>
+          <p:nvPr>
+            <p:ph type="sldImg" idx="2"/>
+          </p:nvPr>
+        </p:nvSpPr>
+        <p:spPr/>
+      </p:sp>
+      <p:sp>
+        <p:nvSpPr>
+          <p:cNvPr id="3" name="Notes Placeholder 2"/>
+          <p:cNvSpPr>
+            <a:spLocks noGrp="1"/>
+          </p:cNvSpPr>
+          <p:nvPr>
+            <p:ph type="body" idx="3" sz="quarter"/>
+          </p:nvPr>
+        </p:nvSpPr>
+        <p:spPr/>
+        <p:txBody>
+          <a:bodyPr/>
+          <a:lstStyle/>
+          <a:p>
+            <a:r>
+              <a:t>11/20</a:t>
+            </a:r>
+          </a:p>
+          <a:p/>
+          <a:p>
+            <a:r>
+              <a:t>How a venue works. Every table has its own code, the guest taps it, and the request lands at the till with the table number and a sound. The waiter is not scanning the room for a raised hand — the screen says which table.</a:t>
+            </a:r>
+          </a:p>
+        </p:txBody>
+      </p:sp>
+      <p:sp>
+        <p:nvSpPr>
+          <p:cNvPr id="4" name="Slide Number Placeholder 3"/>
+          <p:cNvSpPr>
+            <a:spLocks noGrp="1"/>
+          </p:cNvSpPr>
+          <p:nvPr>
+            <p:ph type="sldNum" idx="5" sz="quarter"/>
+          </p:nvPr>
+        </p:nvSpPr>
+        <p:spPr/>
+      </p:sp>
+    </p:spTree>
+  </p:cSld>
+  <p:clrMapOvr>
+    <a:masterClrMapping/>
+  </p:clrMapOvr>
+</p:notes>
+</file>
+
+<file path=ppt/notesSlides/notesSlide12.xml><?xml version="1.0" encoding="utf-8"?>
+<p:notes xmlns:a="http://schemas.openxmlformats.org/drawingml/2006/main" xmlns:p="http://schemas.openxmlformats.org/presentationml/2006/main" xmlns:r="http://schemas.openxmlformats.org/officeDocument/2006/relationships">
+  <p:cSld>
+    <p:spTree>
+      <p:nvGrpSpPr>
+        <p:cNvPr id="1" name=""/>
+        <p:cNvGrpSpPr/>
+        <p:nvPr/>
+      </p:nvGrpSpPr>
+      <p:grpSpPr>
+        <a:xfrm>
+          <a:off x="0" y="0"/>
+          <a:ext cx="0" cy="0"/>
+          <a:chOff x="0" y="0"/>
+          <a:chExt cx="0" cy="0"/>
+        </a:xfrm>
+      </p:grpSpPr>
+      <p:sp>
+        <p:nvSpPr>
+          <p:cNvPr id="2" name="Slide Image Placeholder 1"/>
+          <p:cNvSpPr>
+            <a:spLocks noGrp="1"/>
+          </p:cNvSpPr>
+          <p:nvPr>
+            <p:ph type="sldImg" idx="2"/>
+          </p:nvPr>
+        </p:nvSpPr>
+        <p:spPr/>
+      </p:sp>
+      <p:sp>
+        <p:nvSpPr>
+          <p:cNvPr id="3" name="Notes Placeholder 2"/>
+          <p:cNvSpPr>
+            <a:spLocks noGrp="1"/>
+          </p:cNvSpPr>
+          <p:nvPr>
+            <p:ph type="body" idx="3" sz="quarter"/>
+          </p:nvPr>
+        </p:nvSpPr>
+        <p:spPr/>
+        <p:txBody>
+          <a:bodyPr/>
+          <a:lstStyle/>
+          <a:p>
+            <a:r>
+              <a:t>12/20</a:t>
+            </a:r>
+          </a:p>
+          <a:p/>
+          <a:p>
+            <a:r>
+              <a:t>That is the whole installation. The owner types the tables, prints the sheet, and puts one card on each table. No engineer visits. Printed on Monday, answering by Tuesday.</a:t>
+            </a:r>
+          </a:p>
+        </p:txBody>
+      </p:sp>
+      <p:sp>
+        <p:nvSpPr>
+          <p:cNvPr id="4" name="Slide Number Placeholder 3"/>
+          <p:cNvSpPr>
+            <a:spLocks noGrp="1"/>
+          </p:cNvSpPr>
+          <p:nvPr>
+            <p:ph type="sldNum" idx="5" sz="quarter"/>
+          </p:nvPr>
+        </p:nvSpPr>
+        <p:spPr/>
+      </p:sp>
+    </p:spTree>
+  </p:cSld>
+  <p:clrMapOvr>
+    <a:masterClrMapping/>
+  </p:clrMapOvr>
+</p:notes>
+</file>
+
+<file path=ppt/notesSlides/notesSlide13.xml><?xml version="1.0" encoding="utf-8"?>
+<p:notes xmlns:a="http://schemas.openxmlformats.org/drawingml/2006/main" xmlns:p="http://schemas.openxmlformats.org/presentationml/2006/main" xmlns:r="http://schemas.openxmlformats.org/officeDocument/2006/relationships">
+  <p:cSld>
+    <p:spTree>
+      <p:nvGrpSpPr>
+        <p:cNvPr id="1" name=""/>
+        <p:cNvGrpSpPr/>
+        <p:nvPr/>
+      </p:nvGrpSpPr>
+      <p:grpSpPr>
+        <a:xfrm>
+          <a:off x="0" y="0"/>
+          <a:ext cx="0" cy="0"/>
+          <a:chOff x="0" y="0"/>
+          <a:chExt cx="0" cy="0"/>
+        </a:xfrm>
+      </p:grpSpPr>
+      <p:sp>
+        <p:nvSpPr>
+          <p:cNvPr id="2" name="Slide Image Placeholder 1"/>
+          <p:cNvSpPr>
+            <a:spLocks noGrp="1"/>
+          </p:cNvSpPr>
+          <p:nvPr>
+            <p:ph type="sldImg" idx="2"/>
+          </p:nvPr>
+        </p:nvSpPr>
+        <p:spPr/>
+      </p:sp>
+      <p:sp>
+        <p:nvSpPr>
+          <p:cNvPr id="3" name="Notes Placeholder 2"/>
+          <p:cNvSpPr>
+            <a:spLocks noGrp="1"/>
+          </p:cNvSpPr>
+          <p:nvPr>
+            <p:ph type="body" idx="3" sz="quarter"/>
+          </p:nvPr>
+        </p:nvSpPr>
+        <p:spPr/>
+        <p:txBody>
+          <a:bodyPr/>
+          <a:lstStyle/>
+          <a:p>
+            <a:r>
+              <a:t>13/20</a:t>
+            </a:r>
+          </a:p>
+          <a:p/>
+          <a:p>
+            <a:r>
+              <a:t>Two kinds of money. The number and the object are one-off. The venue is monthly. Companies pay by invoice, because that is how business pays here; offer a card payment and the accountant refuses.</a:t>
+            </a:r>
+          </a:p>
+        </p:txBody>
+      </p:sp>
+      <p:sp>
+        <p:nvSpPr>
+          <p:cNvPr id="4" name="Slide Number Placeholder 3"/>
+          <p:cNvSpPr>
+            <a:spLocks noGrp="1"/>
+          </p:cNvSpPr>
+          <p:nvPr>
+            <p:ph type="sldNum" idx="5" sz="quarter"/>
+          </p:nvPr>
+        </p:nvSpPr>
+        <p:spPr/>
+      </p:sp>
+    </p:spTree>
+  </p:cSld>
+  <p:clrMapOvr>
+    <a:masterClrMapping/>
+  </p:clrMapOvr>
+</p:notes>
+</file>
+
+<file path=ppt/notesSlides/notesSlide14.xml><?xml version="1.0" encoding="utf-8"?>
+<p:notes xmlns:a="http://schemas.openxmlformats.org/drawingml/2006/main" xmlns:p="http://schemas.openxmlformats.org/presentationml/2006/main" xmlns:r="http://schemas.openxmlformats.org/officeDocument/2006/relationships">
+  <p:cSld>
+    <p:spTree>
+      <p:nvGrpSpPr>
+        <p:cNvPr id="1" name=""/>
+        <p:cNvGrpSpPr/>
+        <p:nvPr/>
+      </p:nvGrpSpPr>
+      <p:grpSpPr>
+        <a:xfrm>
+          <a:off x="0" y="0"/>
+          <a:ext cx="0" cy="0"/>
+          <a:chOff x="0" y="0"/>
+          <a:chExt cx="0" cy="0"/>
+        </a:xfrm>
+      </p:grpSpPr>
+      <p:sp>
+        <p:nvSpPr>
+          <p:cNvPr id="2" name="Slide Image Placeholder 1"/>
+          <p:cNvSpPr>
+            <a:spLocks noGrp="1"/>
+          </p:cNvSpPr>
+          <p:nvPr>
+            <p:ph type="sldImg" idx="2"/>
+          </p:nvPr>
+        </p:nvSpPr>
+        <p:spPr/>
+      </p:sp>
+      <p:sp>
+        <p:nvSpPr>
+          <p:cNvPr id="3" name="Notes Placeholder 2"/>
+          <p:cNvSpPr>
+            <a:spLocks noGrp="1"/>
+          </p:cNvSpPr>
+          <p:nvPr>
+            <p:ph type="body" idx="3" sz="quarter"/>
+          </p:nvPr>
+        </p:nvSpPr>
+        <p:spPr/>
+        <p:txBody>
+          <a:bodyPr/>
+          <a:lstStyle/>
+          <a:p>
+            <a:r>
+              <a:t>14/20  ·  [3-MINUTE CUT]</a:t>
+            </a:r>
+          </a:p>
+          <a:p/>
+          <a:p>
+            <a:r>
+              <a:t>Simple arithmetic. A thousand venues at the lowest tariff is 149 million soum a month. That is the lowest tariff — a hotel or a larger restaurant pays twice that. Hardware and personal numbers are not counted here.</a:t>
+            </a:r>
+          </a:p>
+        </p:txBody>
+      </p:sp>
+      <p:sp>
+        <p:nvSpPr>
+          <p:cNvPr id="4" name="Slide Number Placeholder 3"/>
+          <p:cNvSpPr>
+            <a:spLocks noGrp="1"/>
+          </p:cNvSpPr>
+          <p:nvPr>
+            <p:ph type="sldNum" idx="5" sz="quarter"/>
+          </p:nvPr>
+        </p:nvSpPr>
+        <p:spPr/>
+      </p:sp>
+    </p:spTree>
+  </p:cSld>
+  <p:clrMapOvr>
+    <a:masterClrMapping/>
+  </p:clrMapOvr>
+</p:notes>
+</file>
+
+<file path=ppt/notesSlides/notesSlide15.xml><?xml version="1.0" encoding="utf-8"?>
+<p:notes xmlns:a="http://schemas.openxmlformats.org/drawingml/2006/main" xmlns:p="http://schemas.openxmlformats.org/presentationml/2006/main" xmlns:r="http://schemas.openxmlformats.org/officeDocument/2006/relationships">
+  <p:cSld>
+    <p:spTree>
+      <p:nvGrpSpPr>
+        <p:cNvPr id="1" name=""/>
+        <p:cNvGrpSpPr/>
+        <p:nvPr/>
+      </p:nvGrpSpPr>
+      <p:grpSpPr>
+        <a:xfrm>
+          <a:off x="0" y="0"/>
+          <a:ext cx="0" cy="0"/>
+          <a:chOff x="0" y="0"/>
+          <a:chExt cx="0" cy="0"/>
+        </a:xfrm>
+      </p:grpSpPr>
+      <p:sp>
+        <p:nvSpPr>
+          <p:cNvPr id="2" name="Slide Image Placeholder 1"/>
+          <p:cNvSpPr>
+            <a:spLocks noGrp="1"/>
+          </p:cNvSpPr>
+          <p:nvPr>
+            <p:ph type="sldImg" idx="2"/>
+          </p:nvPr>
+        </p:nvSpPr>
+        <p:spPr/>
+      </p:sp>
+      <p:sp>
+        <p:nvSpPr>
+          <p:cNvPr id="3" name="Notes Placeholder 2"/>
+          <p:cNvSpPr>
+            <a:spLocks noGrp="1"/>
+          </p:cNvSpPr>
+          <p:nvPr>
+            <p:ph type="body" idx="3" sz="quarter"/>
+          </p:nvPr>
+        </p:nvSpPr>
+        <p:spPr/>
+        <p:txBody>
+          <a:bodyPr/>
+          <a:lstStyle/>
+          <a:p>
+            <a:r>
+              <a:t>15/20</a:t>
+            </a:r>
+          </a:p>
+          <a:p/>
+          <a:p>
+            <a:r>
+              <a:t>This is not a first attempt. We are an IT Park resident, we have been through accelerators, and we have sold hardware into cafes, shops, clothing stores and clinics. We deal directly with the manufacturers, which means we control what the hardware costs us.</a:t>
+            </a:r>
+          </a:p>
+        </p:txBody>
+      </p:sp>
+      <p:sp>
+        <p:nvSpPr>
+          <p:cNvPr id="4" name="Slide Number Placeholder 3"/>
+          <p:cNvSpPr>
+            <a:spLocks noGrp="1"/>
+          </p:cNvSpPr>
+          <p:nvPr>
+            <p:ph type="sldNum" idx="5" sz="quarter"/>
+          </p:nvPr>
+        </p:nvSpPr>
+        <p:spPr/>
+      </p:sp>
+    </p:spTree>
+  </p:cSld>
+  <p:clrMapOvr>
+    <a:masterClrMapping/>
+  </p:clrMapOvr>
+</p:notes>
+</file>
+
+<file path=ppt/notesSlides/notesSlide16.xml><?xml version="1.0" encoding="utf-8"?>
+<p:notes xmlns:a="http://schemas.openxmlformats.org/drawingml/2006/main" xmlns:p="http://schemas.openxmlformats.org/presentationml/2006/main" xmlns:r="http://schemas.openxmlformats.org/officeDocument/2006/relationships">
+  <p:cSld>
+    <p:spTree>
+      <p:nvGrpSpPr>
+        <p:cNvPr id="1" name=""/>
+        <p:cNvGrpSpPr/>
+        <p:nvPr/>
+      </p:nvGrpSpPr>
+      <p:grpSpPr>
+        <a:xfrm>
+          <a:off x="0" y="0"/>
+          <a:ext cx="0" cy="0"/>
+          <a:chOff x="0" y="0"/>
+          <a:chExt cx="0" cy="0"/>
+        </a:xfrm>
+      </p:grpSpPr>
+      <p:sp>
+        <p:nvSpPr>
+          <p:cNvPr id="2" name="Slide Image Placeholder 1"/>
+          <p:cNvSpPr>
+            <a:spLocks noGrp="1"/>
+          </p:cNvSpPr>
+          <p:nvPr>
+            <p:ph type="sldImg" idx="2"/>
+          </p:nvPr>
+        </p:nvSpPr>
+        <p:spPr/>
+      </p:sp>
+      <p:sp>
+        <p:nvSpPr>
+          <p:cNvPr id="3" name="Notes Placeholder 2"/>
+          <p:cNvSpPr>
+            <a:spLocks noGrp="1"/>
+          </p:cNvSpPr>
+          <p:nvPr>
+            <p:ph type="body" idx="3" sz="quarter"/>
+          </p:nvPr>
+        </p:nvSpPr>
+        <p:spPr/>
+        <p:txBody>
+          <a:bodyPr/>
+          <a:lstStyle/>
+          <a:p>
+            <a:r>
+              <a:t>16/20  ·  [3-MINUTE CUT]</a:t>
+            </a:r>
+          </a:p>
+          <a:p/>
+          <a:p>
+            <a:r>
+              <a:t>This is the only real photograph in the deck — the rest are renders. A real cafe, a real table, hardware that is working. The list on the left is what runs today, not what we plan.</a:t>
+            </a:r>
+          </a:p>
+        </p:txBody>
+      </p:sp>
+      <p:sp>
+        <p:nvSpPr>
+          <p:cNvPr id="4" name="Slide Number Placeholder 3"/>
+          <p:cNvSpPr>
+            <a:spLocks noGrp="1"/>
+          </p:cNvSpPr>
+          <p:nvPr>
+            <p:ph type="sldNum" idx="5" sz="quarter"/>
+          </p:nvPr>
+        </p:nvSpPr>
+        <p:spPr/>
+      </p:sp>
+    </p:spTree>
+  </p:cSld>
+  <p:clrMapOvr>
+    <a:masterClrMapping/>
+  </p:clrMapOvr>
+</p:notes>
+</file>
+
+<file path=ppt/notesSlides/notesSlide17.xml><?xml version="1.0" encoding="utf-8"?>
+<p:notes xmlns:a="http://schemas.openxmlformats.org/drawingml/2006/main" xmlns:p="http://schemas.openxmlformats.org/presentationml/2006/main" xmlns:r="http://schemas.openxmlformats.org/officeDocument/2006/relationships">
+  <p:cSld>
+    <p:spTree>
+      <p:nvGrpSpPr>
+        <p:cNvPr id="1" name=""/>
+        <p:cNvGrpSpPr/>
+        <p:nvPr/>
+      </p:nvGrpSpPr>
+      <p:grpSpPr>
+        <a:xfrm>
+          <a:off x="0" y="0"/>
+          <a:ext cx="0" cy="0"/>
+          <a:chOff x="0" y="0"/>
+          <a:chExt cx="0" cy="0"/>
+        </a:xfrm>
+      </p:grpSpPr>
+      <p:sp>
+        <p:nvSpPr>
+          <p:cNvPr id="2" name="Slide Image Placeholder 1"/>
+          <p:cNvSpPr>
+            <a:spLocks noGrp="1"/>
+          </p:cNvSpPr>
+          <p:nvPr>
+            <p:ph type="sldImg" idx="2"/>
+          </p:nvPr>
+        </p:nvSpPr>
+        <p:spPr/>
+      </p:sp>
+      <p:sp>
+        <p:nvSpPr>
+          <p:cNvPr id="3" name="Notes Placeholder 2"/>
+          <p:cNvSpPr>
+            <a:spLocks noGrp="1"/>
+          </p:cNvSpPr>
+          <p:nvPr>
+            <p:ph type="body" idx="3" sz="quarter"/>
+          </p:nvPr>
+        </p:nvSpPr>
+        <p:spPr/>
+        <p:txBody>
+          <a:bodyPr/>
+          <a:lstStyle/>
+          <a:p>
+            <a:r>
+              <a:t>17/20</a:t>
+            </a:r>
+          </a:p>
+          <a:p/>
+          <a:p>
+            <a:r>
+              <a:t>Eighteen months. First quarter: Payme certification and a hundred venues. Then widening the product, then a dealer network, then the neighbouring markets. The dates run from the close of the round.</a:t>
+            </a:r>
+          </a:p>
+        </p:txBody>
+      </p:sp>
+      <p:sp>
+        <p:nvSpPr>
+          <p:cNvPr id="4" name="Slide Number Placeholder 3"/>
+          <p:cNvSpPr>
+            <a:spLocks noGrp="1"/>
+          </p:cNvSpPr>
+          <p:nvPr>
+            <p:ph type="sldNum" idx="5" sz="quarter"/>
+          </p:nvPr>
+        </p:nvSpPr>
+        <p:spPr/>
+      </p:sp>
+    </p:spTree>
+  </p:cSld>
+  <p:clrMapOvr>
+    <a:masterClrMapping/>
+  </p:clrMapOvr>
+</p:notes>
+</file>
+
+<file path=ppt/notesSlides/notesSlide18.xml><?xml version="1.0" encoding="utf-8"?>
+<p:notes xmlns:a="http://schemas.openxmlformats.org/drawingml/2006/main" xmlns:p="http://schemas.openxmlformats.org/presentationml/2006/main" xmlns:r="http://schemas.openxmlformats.org/officeDocument/2006/relationships">
+  <p:cSld>
+    <p:spTree>
+      <p:nvGrpSpPr>
+        <p:cNvPr id="1" name=""/>
+        <p:cNvGrpSpPr/>
+        <p:nvPr/>
+      </p:nvGrpSpPr>
+      <p:grpSpPr>
+        <a:xfrm>
+          <a:off x="0" y="0"/>
+          <a:ext cx="0" cy="0"/>
+          <a:chOff x="0" y="0"/>
+          <a:chExt cx="0" cy="0"/>
+        </a:xfrm>
+      </p:grpSpPr>
+      <p:sp>
+        <p:nvSpPr>
+          <p:cNvPr id="2" name="Slide Image Placeholder 1"/>
+          <p:cNvSpPr>
+            <a:spLocks noGrp="1"/>
+          </p:cNvSpPr>
+          <p:nvPr>
+            <p:ph type="sldImg" idx="2"/>
+          </p:nvPr>
+        </p:nvSpPr>
+        <p:spPr/>
+      </p:sp>
+      <p:sp>
+        <p:nvSpPr>
+          <p:cNvPr id="3" name="Notes Placeholder 2"/>
+          <p:cNvSpPr>
+            <a:spLocks noGrp="1"/>
+          </p:cNvSpPr>
+          <p:nvPr>
+            <p:ph type="body" idx="3" sz="quarter"/>
+          </p:nvPr>
+        </p:nvSpPr>
+        <p:spPr/>
+        <p:txBody>
+          <a:bodyPr/>
+          <a:lstStyle/>
+          <a:p>
+            <a:r>
+              <a:t>18/20</a:t>
+            </a:r>
+          </a:p>
+          <a:p/>
+          <a:p>
+            <a:r>
+              <a:t>Why now. The phones are ready — NFC is in all of them and nobody needs QR explained. Cafes compete on service, not only price. And the payment rails exist: collecting a monthly subscription from a business is now possible.</a:t>
+            </a:r>
+          </a:p>
+        </p:txBody>
+      </p:sp>
+      <p:sp>
+        <p:nvSpPr>
+          <p:cNvPr id="4" name="Slide Number Placeholder 3"/>
+          <p:cNvSpPr>
+            <a:spLocks noGrp="1"/>
+          </p:cNvSpPr>
+          <p:nvPr>
+            <p:ph type="sldNum" idx="5" sz="quarter"/>
+          </p:nvPr>
+        </p:nvSpPr>
+        <p:spPr/>
+      </p:sp>
+    </p:spTree>
+  </p:cSld>
+  <p:clrMapOvr>
+    <a:masterClrMapping/>
+  </p:clrMapOvr>
+</p:notes>
+</file>
+
+<file path=ppt/notesSlides/notesSlide19.xml><?xml version="1.0" encoding="utf-8"?>
+<p:notes xmlns:a="http://schemas.openxmlformats.org/drawingml/2006/main" xmlns:p="http://schemas.openxmlformats.org/presentationml/2006/main" xmlns:r="http://schemas.openxmlformats.org/officeDocument/2006/relationships">
+  <p:cSld>
+    <p:spTree>
+      <p:nvGrpSpPr>
+        <p:cNvPr id="1" name=""/>
+        <p:cNvGrpSpPr/>
+        <p:nvPr/>
+      </p:nvGrpSpPr>
+      <p:grpSpPr>
+        <a:xfrm>
+          <a:off x="0" y="0"/>
+          <a:ext cx="0" cy="0"/>
+          <a:chOff x="0" y="0"/>
+          <a:chExt cx="0" cy="0"/>
+        </a:xfrm>
+      </p:grpSpPr>
+      <p:sp>
+        <p:nvSpPr>
+          <p:cNvPr id="2" name="Slide Image Placeholder 1"/>
+          <p:cNvSpPr>
+            <a:spLocks noGrp="1"/>
+          </p:cNvSpPr>
+          <p:nvPr>
+            <p:ph type="sldImg" idx="2"/>
+          </p:nvPr>
+        </p:nvSpPr>
+        <p:spPr/>
+      </p:sp>
+      <p:sp>
+        <p:nvSpPr>
+          <p:cNvPr id="3" name="Notes Placeholder 2"/>
+          <p:cNvSpPr>
+            <a:spLocks noGrp="1"/>
+          </p:cNvSpPr>
+          <p:nvPr>
+            <p:ph type="body" idx="3" sz="quarter"/>
+          </p:nvPr>
+        </p:nvSpPr>
+        <p:spPr/>
+        <p:txBody>
+          <a:bodyPr/>
+          <a:lstStyle/>
+          <a:p>
+            <a:r>
+              <a:t>19/20</a:t>
+            </a:r>
+          </a:p>
+          <a:p/>
+          <a:p>
+            <a:r>
+              <a:t>Three people. Product, web and sales, all in-house. The first version was built without an outside team, and it is running today.</a:t>
+            </a:r>
+          </a:p>
+        </p:txBody>
+      </p:sp>
+      <p:sp>
+        <p:nvSpPr>
+          <p:cNvPr id="4" name="Slide Number Placeholder 3"/>
+          <p:cNvSpPr>
+            <a:spLocks noGrp="1"/>
+          </p:cNvSpPr>
+          <p:nvPr>
+            <p:ph type="sldNum" idx="5" sz="quarter"/>
+          </p:nvPr>
+        </p:nvSpPr>
+        <p:spPr/>
+      </p:sp>
+    </p:spTree>
+  </p:cSld>
+  <p:clrMapOvr>
+    <a:masterClrMapping/>
+  </p:clrMapOvr>
+</p:notes>
+</file>
+
+<file path=ppt/notesSlides/notesSlide2.xml><?xml version="1.0" encoding="utf-8"?>
+<p:notes xmlns:a="http://schemas.openxmlformats.org/drawingml/2006/main" xmlns:p="http://schemas.openxmlformats.org/presentationml/2006/main" xmlns:r="http://schemas.openxmlformats.org/officeDocument/2006/relationships">
+  <p:cSld>
+    <p:spTree>
+      <p:nvGrpSpPr>
+        <p:cNvPr id="1" name=""/>
+        <p:cNvGrpSpPr/>
+        <p:nvPr/>
+      </p:nvGrpSpPr>
+      <p:grpSpPr>
+        <a:xfrm>
+          <a:off x="0" y="0"/>
+          <a:ext cx="0" cy="0"/>
+          <a:chOff x="0" y="0"/>
+          <a:chExt cx="0" cy="0"/>
+        </a:xfrm>
+      </p:grpSpPr>
+      <p:sp>
+        <p:nvSpPr>
+          <p:cNvPr id="2" name="Slide Image Placeholder 1"/>
+          <p:cNvSpPr>
+            <a:spLocks noGrp="1"/>
+          </p:cNvSpPr>
+          <p:nvPr>
+            <p:ph type="sldImg" idx="2"/>
+          </p:nvPr>
+        </p:nvSpPr>
+        <p:spPr/>
+      </p:sp>
+      <p:sp>
+        <p:nvSpPr>
+          <p:cNvPr id="3" name="Notes Placeholder 2"/>
+          <p:cNvSpPr>
+            <a:spLocks noGrp="1"/>
+          </p:cNvSpPr>
+          <p:nvPr>
+            <p:ph type="body" idx="3" sz="quarter"/>
+          </p:nvPr>
+        </p:nvSpPr>
+        <p:spPr/>
+        <p:txBody>
+          <a:bodyPr/>
+          <a:lstStyle/>
+          <a:p>
+            <a:r>
+              <a:t>2/20  ·  [3-MINUTE CUT]</a:t>
+            </a:r>
+          </a:p>
+          <a:p/>
+          <a:p>
+            <a:r>
+              <a:t>Eight situations, all from one cause: paper is printed once and life keeps changing. The number on the card changes, the price on the menu goes up, and there is no number behind the windscreen at all. We did not invent this list — customers gave us every line of it.</a:t>
+            </a:r>
+          </a:p>
+        </p:txBody>
+      </p:sp>
+      <p:sp>
+        <p:nvSpPr>
+          <p:cNvPr id="4" name="Slide Number Placeholder 3"/>
+          <p:cNvSpPr>
+            <a:spLocks noGrp="1"/>
+          </p:cNvSpPr>
+          <p:nvPr>
+            <p:ph type="sldNum" idx="5" sz="quarter"/>
+          </p:nvPr>
+        </p:nvSpPr>
+        <p:spPr/>
+      </p:sp>
+    </p:spTree>
+  </p:cSld>
+  <p:clrMapOvr>
+    <a:masterClrMapping/>
+  </p:clrMapOvr>
+</p:notes>
+</file>
+
+<file path=ppt/notesSlides/notesSlide20.xml><?xml version="1.0" encoding="utf-8"?>
+<p:notes xmlns:a="http://schemas.openxmlformats.org/drawingml/2006/main" xmlns:p="http://schemas.openxmlformats.org/presentationml/2006/main" xmlns:r="http://schemas.openxmlformats.org/officeDocument/2006/relationships">
+  <p:cSld>
+    <p:spTree>
+      <p:nvGrpSpPr>
+        <p:cNvPr id="1" name=""/>
+        <p:cNvGrpSpPr/>
+        <p:nvPr/>
+      </p:nvGrpSpPr>
+      <p:grpSpPr>
+        <a:xfrm>
+          <a:off x="0" y="0"/>
+          <a:ext cx="0" cy="0"/>
+          <a:chOff x="0" y="0"/>
+          <a:chExt cx="0" cy="0"/>
+        </a:xfrm>
+      </p:grpSpPr>
+      <p:sp>
+        <p:nvSpPr>
+          <p:cNvPr id="2" name="Slide Image Placeholder 1"/>
+          <p:cNvSpPr>
+            <a:spLocks noGrp="1"/>
+          </p:cNvSpPr>
+          <p:nvPr>
+            <p:ph type="sldImg" idx="2"/>
+          </p:nvPr>
+        </p:nvSpPr>
+        <p:spPr/>
+      </p:sp>
+      <p:sp>
+        <p:nvSpPr>
+          <p:cNvPr id="3" name="Notes Placeholder 2"/>
+          <p:cNvSpPr>
+            <a:spLocks noGrp="1"/>
+          </p:cNvSpPr>
+          <p:nvPr>
+            <p:ph type="body" idx="3" sz="quarter"/>
+          </p:nvPr>
+        </p:nvSpPr>
+        <p:spPr/>
+        <p:txBody>
+          <a:bodyPr/>
+          <a:lstStyle/>
+          <a:p>
+            <a:r>
+              <a:t>20/20  ·  [3-MINUTE CUT]</a:t>
+            </a:r>
+          </a:p>
+          <a:p/>
+          <a:p>
+            <a:r>
+              <a:t>Fifty to a hundred thousand dollars, pre-seed. More than half goes to hardware stock and installing the first hundred venues — that is to selling, not to building. The product is already built. Thank you.</a:t>
+            </a:r>
+          </a:p>
+        </p:txBody>
+      </p:sp>
+      <p:sp>
+        <p:nvSpPr>
+          <p:cNvPr id="4" name="Slide Number Placeholder 3"/>
+          <p:cNvSpPr>
+            <a:spLocks noGrp="1"/>
+          </p:cNvSpPr>
+          <p:nvPr>
+            <p:ph type="sldNum" idx="5" sz="quarter"/>
+          </p:nvPr>
+        </p:nvSpPr>
+        <p:spPr/>
+      </p:sp>
+    </p:spTree>
+  </p:cSld>
+  <p:clrMapOvr>
+    <a:masterClrMapping/>
+  </p:clrMapOvr>
+</p:notes>
+</file>
+
+<file path=ppt/notesSlides/notesSlide3.xml><?xml version="1.0" encoding="utf-8"?>
+<p:notes xmlns:a="http://schemas.openxmlformats.org/drawingml/2006/main" xmlns:p="http://schemas.openxmlformats.org/presentationml/2006/main" xmlns:r="http://schemas.openxmlformats.org/officeDocument/2006/relationships">
+  <p:cSld>
+    <p:spTree>
+      <p:nvGrpSpPr>
+        <p:cNvPr id="1" name=""/>
+        <p:cNvGrpSpPr/>
+        <p:nvPr/>
+      </p:nvGrpSpPr>
+      <p:grpSpPr>
+        <a:xfrm>
+          <a:off x="0" y="0"/>
+          <a:ext cx="0" cy="0"/>
+          <a:chOff x="0" y="0"/>
+          <a:chExt cx="0" cy="0"/>
+        </a:xfrm>
+      </p:grpSpPr>
+      <p:sp>
+        <p:nvSpPr>
+          <p:cNvPr id="2" name="Slide Image Placeholder 1"/>
+          <p:cNvSpPr>
+            <a:spLocks noGrp="1"/>
+          </p:cNvSpPr>
+          <p:nvPr>
+            <p:ph type="sldImg" idx="2"/>
+          </p:nvPr>
+        </p:nvSpPr>
+        <p:spPr/>
+      </p:sp>
+      <p:sp>
+        <p:nvSpPr>
+          <p:cNvPr id="3" name="Notes Placeholder 2"/>
+          <p:cNvSpPr>
+            <a:spLocks noGrp="1"/>
+          </p:cNvSpPr>
+          <p:nvPr>
+            <p:ph type="body" idx="3" sz="quarter"/>
+          </p:nvPr>
+        </p:nvSpPr>
+        <p:spPr/>
+        <p:txBody>
+          <a:bodyPr/>
+          <a:lstStyle/>
+          <a:p>
+            <a:r>
+              <a:t>3/20</a:t>
+            </a:r>
+          </a:p>
+          <a:p/>
+          <a:p>
+            <a:r>
+              <a:t>The answer is one mechanism. A tap, and the page opens. Nothing to install, nothing to sign up for, nothing to download. That sentence explains the whole product.</a:t>
+            </a:r>
+          </a:p>
+        </p:txBody>
+      </p:sp>
+      <p:sp>
+        <p:nvSpPr>
+          <p:cNvPr id="4" name="Slide Number Placeholder 3"/>
+          <p:cNvSpPr>
+            <a:spLocks noGrp="1"/>
+          </p:cNvSpPr>
+          <p:nvPr>
+            <p:ph type="sldNum" idx="5" sz="quarter"/>
+          </p:nvPr>
+        </p:nvSpPr>
+        <p:spPr/>
+      </p:sp>
+    </p:spTree>
+  </p:cSld>
+  <p:clrMapOvr>
+    <a:masterClrMapping/>
+  </p:clrMapOvr>
+</p:notes>
+</file>
+
+<file path=ppt/notesSlides/notesSlide4.xml><?xml version="1.0" encoding="utf-8"?>
+<p:notes xmlns:a="http://schemas.openxmlformats.org/drawingml/2006/main" xmlns:p="http://schemas.openxmlformats.org/presentationml/2006/main" xmlns:r="http://schemas.openxmlformats.org/officeDocument/2006/relationships">
+  <p:cSld>
+    <p:spTree>
+      <p:nvGrpSpPr>
+        <p:cNvPr id="1" name=""/>
+        <p:cNvGrpSpPr/>
+        <p:nvPr/>
+      </p:nvGrpSpPr>
+      <p:grpSpPr>
+        <a:xfrm>
+          <a:off x="0" y="0"/>
+          <a:ext cx="0" cy="0"/>
+          <a:chOff x="0" y="0"/>
+          <a:chExt cx="0" cy="0"/>
+        </a:xfrm>
+      </p:grpSpPr>
+      <p:sp>
+        <p:nvSpPr>
+          <p:cNvPr id="2" name="Slide Image Placeholder 1"/>
+          <p:cNvSpPr>
+            <a:spLocks noGrp="1"/>
+          </p:cNvSpPr>
+          <p:nvPr>
+            <p:ph type="sldImg" idx="2"/>
+          </p:nvPr>
+        </p:nvSpPr>
+        <p:spPr/>
+      </p:sp>
+      <p:sp>
+        <p:nvSpPr>
+          <p:cNvPr id="3" name="Notes Placeholder 2"/>
+          <p:cNvSpPr>
+            <a:spLocks noGrp="1"/>
+          </p:cNvSpPr>
+          <p:nvPr>
+            <p:ph type="body" idx="3" sz="quarter"/>
+          </p:nvPr>
+        </p:nvSpPr>
+        <p:spPr/>
+        <p:txBody>
+          <a:bodyPr/>
+          <a:lstStyle/>
+          <a:p>
+            <a:r>
+              <a:t>4/20  ·  [3-MINUTE CUT]</a:t>
+            </a:r>
+          </a:p>
+          <a:p/>
+          <a:p>
+            <a:r>
+              <a:t>The eight problems on the left, the answer on the right. Note that none of these is something we intend to build — all of it works today. We are not listing problems and offering one fix; one mechanism works in eight places.</a:t>
+            </a:r>
+          </a:p>
+        </p:txBody>
+      </p:sp>
+      <p:sp>
+        <p:nvSpPr>
+          <p:cNvPr id="4" name="Slide Number Placeholder 3"/>
+          <p:cNvSpPr>
+            <a:spLocks noGrp="1"/>
+          </p:cNvSpPr>
+          <p:nvPr>
+            <p:ph type="sldNum" idx="5" sz="quarter"/>
+          </p:nvPr>
+        </p:nvSpPr>
+        <p:spPr/>
+      </p:sp>
+    </p:spTree>
+  </p:cSld>
+  <p:clrMapOvr>
+    <a:masterClrMapping/>
+  </p:clrMapOvr>
+</p:notes>
+</file>
+
+<file path=ppt/notesSlides/notesSlide5.xml><?xml version="1.0" encoding="utf-8"?>
+<p:notes xmlns:a="http://schemas.openxmlformats.org/drawingml/2006/main" xmlns:p="http://schemas.openxmlformats.org/presentationml/2006/main" xmlns:r="http://schemas.openxmlformats.org/officeDocument/2006/relationships">
+  <p:cSld>
+    <p:spTree>
+      <p:nvGrpSpPr>
+        <p:cNvPr id="1" name=""/>
+        <p:cNvGrpSpPr/>
+        <p:nvPr/>
+      </p:nvGrpSpPr>
+      <p:grpSpPr>
+        <a:xfrm>
+          <a:off x="0" y="0"/>
+          <a:ext cx="0" cy="0"/>
+          <a:chOff x="0" y="0"/>
+          <a:chExt cx="0" cy="0"/>
+        </a:xfrm>
+      </p:grpSpPr>
+      <p:sp>
+        <p:nvSpPr>
+          <p:cNvPr id="2" name="Slide Image Placeholder 1"/>
+          <p:cNvSpPr>
+            <a:spLocks noGrp="1"/>
+          </p:cNvSpPr>
+          <p:nvPr>
+            <p:ph type="sldImg" idx="2"/>
+          </p:nvPr>
+        </p:nvSpPr>
+        <p:spPr/>
+      </p:sp>
+      <p:sp>
+        <p:nvSpPr>
+          <p:cNvPr id="3" name="Notes Placeholder 2"/>
+          <p:cNvSpPr>
+            <a:spLocks noGrp="1"/>
+          </p:cNvSpPr>
+          <p:nvPr>
+            <p:ph type="body" idx="3" sz="quarter"/>
+          </p:nvPr>
+        </p:nvSpPr>
+        <p:spPr/>
+        <p:txBody>
+          <a:bodyPr/>
+          <a:lstStyle/>
+          <a:p>
+            <a:r>
+              <a:t>5/20</a:t>
+            </a:r>
+          </a:p>
+          <a:p/>
+          <a:p>
+            <a:r>
+              <a:t>This is the part you can hold. Eight form factors, one system. Card, ring and bracelet are a one-off sale. The four below go into venues and come with the subscription. Prices are on the slide.</a:t>
+            </a:r>
+          </a:p>
+        </p:txBody>
+      </p:sp>
+      <p:sp>
+        <p:nvSpPr>
+          <p:cNvPr id="4" name="Slide Number Placeholder 3"/>
+          <p:cNvSpPr>
+            <a:spLocks noGrp="1"/>
+          </p:cNvSpPr>
+          <p:nvPr>
+            <p:ph type="sldNum" idx="5" sz="quarter"/>
+          </p:nvPr>
+        </p:nvSpPr>
+        <p:spPr/>
+      </p:sp>
+    </p:spTree>
+  </p:cSld>
+  <p:clrMapOvr>
+    <a:masterClrMapping/>
+  </p:clrMapOvr>
+</p:notes>
+</file>
+
+<file path=ppt/notesSlides/notesSlide6.xml><?xml version="1.0" encoding="utf-8"?>
+<p:notes xmlns:a="http://schemas.openxmlformats.org/drawingml/2006/main" xmlns:p="http://schemas.openxmlformats.org/presentationml/2006/main" xmlns:r="http://schemas.openxmlformats.org/officeDocument/2006/relationships">
+  <p:cSld>
+    <p:spTree>
+      <p:nvGrpSpPr>
+        <p:cNvPr id="1" name=""/>
+        <p:cNvGrpSpPr/>
+        <p:nvPr/>
+      </p:nvGrpSpPr>
+      <p:grpSpPr>
+        <a:xfrm>
+          <a:off x="0" y="0"/>
+          <a:ext cx="0" cy="0"/>
+          <a:chOff x="0" y="0"/>
+          <a:chExt cx="0" cy="0"/>
+        </a:xfrm>
+      </p:grpSpPr>
+      <p:sp>
+        <p:nvSpPr>
+          <p:cNvPr id="2" name="Slide Image Placeholder 1"/>
+          <p:cNvSpPr>
+            <a:spLocks noGrp="1"/>
+          </p:cNvSpPr>
+          <p:nvPr>
+            <p:ph type="sldImg" idx="2"/>
+          </p:nvPr>
+        </p:nvSpPr>
+        <p:spPr/>
+      </p:sp>
+      <p:sp>
+        <p:nvSpPr>
+          <p:cNvPr id="3" name="Notes Placeholder 2"/>
+          <p:cNvSpPr>
+            <a:spLocks noGrp="1"/>
+          </p:cNvSpPr>
+          <p:nvPr>
+            <p:ph type="body" idx="3" sz="quarter"/>
+          </p:nvPr>
+        </p:nvSpPr>
+        <p:spPr/>
+        <p:txBody>
+          <a:bodyPr/>
+          <a:lstStyle/>
+          <a:p>
+            <a:r>
+              <a:t>6/20  ·  [3-MINUTE CUT]</a:t>
+            </a:r>
+          </a:p>
+          <a:p/>
+          <a:p>
+            <a:r>
+              <a:t>The question we get most: everybody has an NFC card, what is different. Not the card. The number belongs to the customer, the page changes whenever they like, there are statistics, three languages, Payme is connected — and above all there is the venue half. The card is a piece of metal; the rest is the platform.</a:t>
+            </a:r>
+          </a:p>
+        </p:txBody>
+      </p:sp>
+      <p:sp>
+        <p:nvSpPr>
+          <p:cNvPr id="4" name="Slide Number Placeholder 3"/>
+          <p:cNvSpPr>
+            <a:spLocks noGrp="1"/>
+          </p:cNvSpPr>
+          <p:nvPr>
+            <p:ph type="sldNum" idx="5" sz="quarter"/>
+          </p:nvPr>
+        </p:nvSpPr>
+        <p:spPr/>
+      </p:sp>
+    </p:spTree>
+  </p:cSld>
+  <p:clrMapOvr>
+    <a:masterClrMapping/>
+  </p:clrMapOvr>
+</p:notes>
+</file>
+
+<file path=ppt/notesSlides/notesSlide7.xml><?xml version="1.0" encoding="utf-8"?>
+<p:notes xmlns:a="http://schemas.openxmlformats.org/drawingml/2006/main" xmlns:p="http://schemas.openxmlformats.org/presentationml/2006/main" xmlns:r="http://schemas.openxmlformats.org/officeDocument/2006/relationships">
+  <p:cSld>
+    <p:spTree>
+      <p:nvGrpSpPr>
+        <p:cNvPr id="1" name=""/>
+        <p:cNvGrpSpPr/>
+        <p:nvPr/>
+      </p:nvGrpSpPr>
+      <p:grpSpPr>
+        <a:xfrm>
+          <a:off x="0" y="0"/>
+          <a:ext cx="0" cy="0"/>
+          <a:chOff x="0" y="0"/>
+          <a:chExt cx="0" cy="0"/>
+        </a:xfrm>
+      </p:grpSpPr>
+      <p:sp>
+        <p:nvSpPr>
+          <p:cNvPr id="2" name="Slide Image Placeholder 1"/>
+          <p:cNvSpPr>
+            <a:spLocks noGrp="1"/>
+          </p:cNvSpPr>
+          <p:nvPr>
+            <p:ph type="sldImg" idx="2"/>
+          </p:nvPr>
+        </p:nvSpPr>
+        <p:spPr/>
+      </p:sp>
+      <p:sp>
+        <p:nvSpPr>
+          <p:cNvPr id="3" name="Notes Placeholder 2"/>
+          <p:cNvSpPr>
+            <a:spLocks noGrp="1"/>
+          </p:cNvSpPr>
+          <p:nvPr>
+            <p:ph type="body" idx="3" sz="quarter"/>
+          </p:nvPr>
+        </p:nvSpPr>
+        <p:spPr/>
+        <p:txBody>
+          <a:bodyPr/>
+          <a:lstStyle/>
+          <a:p>
+            <a:r>
+              <a:t>7/20</a:t>
+            </a:r>
+          </a:p>
+          <a:p/>
+          <a:p>
+            <a:r>
+              <a:t>We drew these designs ourselves. A competitor prints a car marque or a cartoon character — that infringes a registered mark, and anyone with the same printer can copy it. A low serial number cannot be copied at all. Buyers can also describe a design in a sentence and have it drawn.</a:t>
+            </a:r>
+          </a:p>
+        </p:txBody>
+      </p:sp>
+      <p:sp>
+        <p:nvSpPr>
+          <p:cNvPr id="4" name="Slide Number Placeholder 3"/>
+          <p:cNvSpPr>
+            <a:spLocks noGrp="1"/>
+          </p:cNvSpPr>
+          <p:nvPr>
+            <p:ph type="sldNum" idx="5" sz="quarter"/>
+          </p:nvPr>
+        </p:nvSpPr>
+        <p:spPr/>
+      </p:sp>
+    </p:spTree>
+  </p:cSld>
+  <p:clrMapOvr>
+    <a:masterClrMapping/>
+  </p:clrMapOvr>
+</p:notes>
+</file>
+
+<file path=ppt/notesSlides/notesSlide8.xml><?xml version="1.0" encoding="utf-8"?>
+<p:notes xmlns:a="http://schemas.openxmlformats.org/drawingml/2006/main" xmlns:p="http://schemas.openxmlformats.org/presentationml/2006/main" xmlns:r="http://schemas.openxmlformats.org/officeDocument/2006/relationships">
+  <p:cSld>
+    <p:spTree>
+      <p:nvGrpSpPr>
+        <p:cNvPr id="1" name=""/>
+        <p:cNvGrpSpPr/>
+        <p:nvPr/>
+      </p:nvGrpSpPr>
+      <p:grpSpPr>
+        <a:xfrm>
+          <a:off x="0" y="0"/>
+          <a:ext cx="0" cy="0"/>
+          <a:chOff x="0" y="0"/>
+          <a:chExt cx="0" cy="0"/>
+        </a:xfrm>
+      </p:grpSpPr>
+      <p:sp>
+        <p:nvSpPr>
+          <p:cNvPr id="2" name="Slide Image Placeholder 1"/>
+          <p:cNvSpPr>
+            <a:spLocks noGrp="1"/>
+          </p:cNvSpPr>
+          <p:nvPr>
+            <p:ph type="sldImg" idx="2"/>
+          </p:nvPr>
+        </p:nvSpPr>
+        <p:spPr/>
+      </p:sp>
+      <p:sp>
+        <p:nvSpPr>
+          <p:cNvPr id="3" name="Notes Placeholder 2"/>
+          <p:cNvSpPr>
+            <a:spLocks noGrp="1"/>
+          </p:cNvSpPr>
+          <p:nvPr>
+            <p:ph type="body" idx="3" sz="quarter"/>
+          </p:nvPr>
+        </p:nvSpPr>
+        <p:spPr/>
+        <p:txBody>
+          <a:bodyPr/>
+          <a:lstStyle/>
+          <a:p>
+            <a:r>
+              <a:t>8/20</a:t>
+            </a:r>
+          </a:p>
+          <a:p/>
+          <a:p>
+            <a:r>
+              <a:t>The rooms we sell into: cafes, hotels, shops and salons, clinics. These are not mockups — every one of them is installed hardware.</a:t>
+            </a:r>
+          </a:p>
+        </p:txBody>
+      </p:sp>
+      <p:sp>
+        <p:nvSpPr>
+          <p:cNvPr id="4" name="Slide Number Placeholder 3"/>
+          <p:cNvSpPr>
+            <a:spLocks noGrp="1"/>
+          </p:cNvSpPr>
+          <p:nvPr>
+            <p:ph type="sldNum" idx="5" sz="quarter"/>
+          </p:nvPr>
+        </p:nvSpPr>
+        <p:spPr/>
+      </p:sp>
+    </p:spTree>
+  </p:cSld>
+  <p:clrMapOvr>
+    <a:masterClrMapping/>
+  </p:clrMapOvr>
+</p:notes>
+</file>
+
+<file path=ppt/notesSlides/notesSlide9.xml><?xml version="1.0" encoding="utf-8"?>
+<p:notes xmlns:a="http://schemas.openxmlformats.org/drawingml/2006/main" xmlns:p="http://schemas.openxmlformats.org/presentationml/2006/main" xmlns:r="http://schemas.openxmlformats.org/officeDocument/2006/relationships">
+  <p:cSld>
+    <p:spTree>
+      <p:nvGrpSpPr>
+        <p:cNvPr id="1" name=""/>
+        <p:cNvGrpSpPr/>
+        <p:nvPr/>
+      </p:nvGrpSpPr>
+      <p:grpSpPr>
+        <a:xfrm>
+          <a:off x="0" y="0"/>
+          <a:ext cx="0" cy="0"/>
+          <a:chOff x="0" y="0"/>
+          <a:chExt cx="0" cy="0"/>
+        </a:xfrm>
+      </p:grpSpPr>
+      <p:sp>
+        <p:nvSpPr>
+          <p:cNvPr id="2" name="Slide Image Placeholder 1"/>
+          <p:cNvSpPr>
+            <a:spLocks noGrp="1"/>
+          </p:cNvSpPr>
+          <p:nvPr>
+            <p:ph type="sldImg" idx="2"/>
+          </p:nvPr>
+        </p:nvSpPr>
+        <p:spPr/>
+      </p:sp>
+      <p:sp>
+        <p:nvSpPr>
+          <p:cNvPr id="3" name="Notes Placeholder 2"/>
+          <p:cNvSpPr>
+            <a:spLocks noGrp="1"/>
+          </p:cNvSpPr>
+          <p:nvPr>
+            <p:ph type="body" idx="3" sz="quarter"/>
+          </p:nvPr>
+        </p:nvSpPr>
+        <p:spPr/>
+        <p:txBody>
+          <a:bodyPr/>
+          <a:lstStyle/>
+          <a:p>
+            <a:r>
+              <a:t>9/20  ·  [3-MINUTE CUT]</a:t>
+            </a:r>
+          </a:p>
+          <a:p/>
+          <a:p>
+            <a:r>
+              <a:t>The figures are the state statistics committee's, with their dates, so you can check them from where you are sitting. 116,900 venues in total. At the lowest tariff that is 209 billion soum a year. Our three-year target is 0.9% of it. We are not talking about owning a market — we are talking about a thousand venues.</a:t>
+            </a:r>
+          </a:p>
+        </p:txBody>
+      </p:sp>
+      <p:sp>
+        <p:nvSpPr>
+          <p:cNvPr id="4" name="Slide Number Placeholder 3"/>
+          <p:cNvSpPr>
+            <a:spLocks noGrp="1"/>
+          </p:cNvSpPr>
+          <p:nvPr>
+            <p:ph type="sldNum" idx="5" sz="quarter"/>
+          </p:nvPr>
+        </p:nvSpPr>
+        <p:spPr/>
+      </p:sp>
+    </p:spTree>
+  </p:cSld>
+  <p:clrMapOvr>
+    <a:masterClrMapping/>
+  </p:clrMapOvr>
+</p:notes>
 </file>
 
 <file path=ppt/slideLayouts/slideLayout1.xml><?xml version="1.0" encoding="utf-8"?>
@@ -25631,4 +27501,324 @@
   </a:objectDefaults>
   <a:extraClrSchemeLst/>
 </a:theme>
+</file>
+
+<file path=ppt/theme/theme2.xml><?xml version="1.0" encoding="utf-8"?>
+<a:theme xmlns:a="http://schemas.openxmlformats.org/drawingml/2006/main" name="Office Theme">
+  <a:themeElements>
+    <a:clrScheme name="Office">
+      <a:dk1>
+        <a:sysClr val="windowText" lastClr="000000"/>
+      </a:dk1>
+      <a:lt1>
+        <a:sysClr val="window" lastClr="FFFFFF"/>
+      </a:lt1>
+      <a:dk2>
+        <a:srgbClr val="1F497D"/>
+      </a:dk2>
+      <a:lt2>
+        <a:srgbClr val="EEECE1"/>
+      </a:lt2>
+      <a:accent1>
+        <a:srgbClr val="4F81BD"/>
+      </a:accent1>
+      <a:accent2>
+        <a:srgbClr val="C0504D"/>
+      </a:accent2>
+      <a:accent3>
+        <a:srgbClr val="9BBB59"/>
+      </a:accent3>
+      <a:accent4>
+        <a:srgbClr val="8064A2"/>
+      </a:accent4>
+      <a:accent5>
+        <a:srgbClr val="4BACC6"/>
+      </a:accent5>
+      <a:accent6>
+        <a:srgbClr val="F79646"/>
+      </a:accent6>
+      <a:hlink>
+        <a:srgbClr val="0000FF"/>
+      </a:hlink>
+      <a:folHlink>
+        <a:srgbClr val="800080"/>
+      </a:folHlink>
+    </a:clrScheme>
+    <a:fontScheme name="Office">
+      <a:majorFont>
+        <a:latin typeface="Calibri"/>
+        <a:ea typeface=""/>
+        <a:cs typeface=""/>
+        <a:font script="Jpan" typeface="ＭＳ Ｐゴシック"/>
+        <a:font script="Hang" typeface="맑은 고딕"/>
+        <a:font script="Hans" typeface="宋体"/>
+        <a:font script="Hant" typeface="新細明體"/>
+        <a:font script="Arab" typeface="Times New Roman"/>
+        <a:font script="Hebr" typeface="Times New Roman"/>
+        <a:font script="Thai" typeface="Angsana New"/>
+        <a:font script="Ethi" typeface="Nyala"/>
+        <a:font script="Beng" typeface="Vrinda"/>
+        <a:font script="Gujr" typeface="Shruti"/>
+        <a:font script="Khmr" typeface="MoolBoran"/>
+        <a:font script="Knda" typeface="Tunga"/>
+        <a:font script="Guru" typeface="Raavi"/>
+        <a:font script="Cans" typeface="Euphemia"/>
+        <a:font script="Cher" typeface="Plantagenet Cherokee"/>
+        <a:font script="Yiii" typeface="Microsoft Yi Baiti"/>
+        <a:font script="Tibt" typeface="Microsoft Himalaya"/>
+        <a:font script="Thaa" typeface="MV Boli"/>
+        <a:font script="Deva" typeface="Mangal"/>
+        <a:font script="Telu" typeface="Gautami"/>
+        <a:font script="Taml" typeface="Latha"/>
+        <a:font script="Syrc" typeface="Estrangelo Edessa"/>
+        <a:font script="Orya" typeface="Kalinga"/>
+        <a:font script="Mlym" typeface="Kartika"/>
+        <a:font script="Laoo" typeface="DokChampa"/>
+        <a:font script="Sinh" typeface="Iskoola Pota"/>
+        <a:font script="Mong" typeface="Mongolian Baiti"/>
+        <a:font script="Viet" typeface="Times New Roman"/>
+        <a:font script="Uigh" typeface="Microsoft Uighur"/>
+        <a:font script="Geor" typeface="Sylfaen"/>
+      </a:majorFont>
+      <a:minorFont>
+        <a:latin typeface="Calibri"/>
+        <a:ea typeface=""/>
+        <a:cs typeface=""/>
+        <a:font script="Jpan" typeface="ＭＳ Ｐゴシック"/>
+        <a:font script="Hang" typeface="맑은 고딕"/>
+        <a:font script="Hans" typeface="宋体"/>
+        <a:font script="Hant" typeface="新細明體"/>
+        <a:font script="Arab" typeface="Arial"/>
+        <a:font script="Hebr" typeface="Arial"/>
+        <a:font script="Thai" typeface="Cordia New"/>
+        <a:font script="Ethi" typeface="Nyala"/>
+        <a:font script="Beng" typeface="Vrinda"/>
+        <a:font script="Gujr" typeface="Shruti"/>
+        <a:font script="Khmr" typeface="DaunPenh"/>
+        <a:font script="Knda" typeface="Tunga"/>
+        <a:font script="Guru" typeface="Raavi"/>
+        <a:font script="Cans" typeface="Euphemia"/>
+        <a:font script="Cher" typeface="Plantagenet Cherokee"/>
+        <a:font script="Yiii" typeface="Microsoft Yi Baiti"/>
+        <a:font script="Tibt" typeface="Microsoft Himalaya"/>
+        <a:font script="Thaa" typeface="MV Boli"/>
+        <a:font script="Deva" typeface="Mangal"/>
+        <a:font script="Telu" typeface="Gautami"/>
+        <a:font script="Taml" typeface="Latha"/>
+        <a:font script="Syrc" typeface="Estrangelo Edessa"/>
+        <a:font script="Orya" typeface="Kalinga"/>
+        <a:font script="Mlym" typeface="Kartika"/>
+        <a:font script="Laoo" typeface="DokChampa"/>
+        <a:font script="Sinh" typeface="Iskoola Pota"/>
+        <a:font script="Mong" typeface="Mongolian Baiti"/>
+        <a:font script="Viet" typeface="Arial"/>
+        <a:font script="Uigh" typeface="Microsoft Uighur"/>
+        <a:font script="Geor" typeface="Sylfaen"/>
+      </a:minorFont>
+    </a:fontScheme>
+    <a:fmtScheme name="Office">
+      <a:fillStyleLst>
+        <a:solidFill>
+          <a:schemeClr val="phClr"/>
+        </a:solidFill>
+        <a:gradFill rotWithShape="1">
+          <a:gsLst>
+            <a:gs pos="0">
+              <a:schemeClr val="phClr">
+                <a:tint val="50000"/>
+                <a:satMod val="300000"/>
+              </a:schemeClr>
+            </a:gs>
+            <a:gs pos="35000">
+              <a:schemeClr val="phClr">
+                <a:tint val="37000"/>
+                <a:satMod val="300000"/>
+              </a:schemeClr>
+            </a:gs>
+            <a:gs pos="100000">
+              <a:schemeClr val="phClr">
+                <a:tint val="15000"/>
+                <a:satMod val="350000"/>
+              </a:schemeClr>
+            </a:gs>
+          </a:gsLst>
+          <a:lin ang="16200000" scaled="1"/>
+        </a:gradFill>
+        <a:gradFill rotWithShape="1">
+          <a:gsLst>
+            <a:gs pos="0">
+              <a:schemeClr val="phClr">
+                <a:tint val="100000"/>
+                <a:shade val="100000"/>
+                <a:satMod val="130000"/>
+              </a:schemeClr>
+            </a:gs>
+            <a:gs pos="100000">
+              <a:schemeClr val="phClr">
+                <a:tint val="50000"/>
+                <a:shade val="100000"/>
+                <a:satMod val="350000"/>
+              </a:schemeClr>
+            </a:gs>
+          </a:gsLst>
+          <a:lin ang="16200000" scaled="0"/>
+        </a:gradFill>
+      </a:fillStyleLst>
+      <a:lnStyleLst>
+        <a:ln w="9525" cap="flat" cmpd="sng" algn="ctr">
+          <a:solidFill>
+            <a:schemeClr val="phClr">
+              <a:shade val="95000"/>
+              <a:satMod val="105000"/>
+            </a:schemeClr>
+          </a:solidFill>
+          <a:prstDash val="solid"/>
+        </a:ln>
+        <a:ln w="25400" cap="flat" cmpd="sng" algn="ctr">
+          <a:solidFill>
+            <a:schemeClr val="phClr"/>
+          </a:solidFill>
+          <a:prstDash val="solid"/>
+        </a:ln>
+        <a:ln w="38100" cap="flat" cmpd="sng" algn="ctr">
+          <a:solidFill>
+            <a:schemeClr val="phClr"/>
+          </a:solidFill>
+          <a:prstDash val="solid"/>
+        </a:ln>
+      </a:lnStyleLst>
+      <a:effectStyleLst>
+        <a:effectStyle>
+          <a:effectLst>
+            <a:outerShdw blurRad="40000" dist="20000" dir="5400000" rotWithShape="0">
+              <a:srgbClr val="000000">
+                <a:alpha val="38000"/>
+              </a:srgbClr>
+            </a:outerShdw>
+          </a:effectLst>
+        </a:effectStyle>
+        <a:effectStyle>
+          <a:effectLst>
+            <a:outerShdw blurRad="40000" dist="23000" dir="5400000" rotWithShape="0">
+              <a:srgbClr val="000000">
+                <a:alpha val="35000"/>
+              </a:srgbClr>
+            </a:outerShdw>
+          </a:effectLst>
+        </a:effectStyle>
+        <a:effectStyle>
+          <a:effectLst>
+            <a:outerShdw blurRad="40000" dist="23000" dir="5400000" rotWithShape="0">
+              <a:srgbClr val="000000">
+                <a:alpha val="35000"/>
+              </a:srgbClr>
+            </a:outerShdw>
+          </a:effectLst>
+          <a:scene3d>
+            <a:camera prst="orthographicFront">
+              <a:rot lat="0" lon="0" rev="0"/>
+            </a:camera>
+            <a:lightRig rig="threePt" dir="t">
+              <a:rot lat="0" lon="0" rev="1200000"/>
+            </a:lightRig>
+          </a:scene3d>
+          <a:sp3d>
+            <a:bevelT w="63500" h="25400"/>
+          </a:sp3d>
+        </a:effectStyle>
+      </a:effectStyleLst>
+      <a:bgFillStyleLst>
+        <a:solidFill>
+          <a:schemeClr val="phClr"/>
+        </a:solidFill>
+        <a:gradFill rotWithShape="1">
+          <a:gsLst>
+            <a:gs pos="0">
+              <a:schemeClr val="phClr">
+                <a:tint val="40000"/>
+                <a:satMod val="350000"/>
+              </a:schemeClr>
+            </a:gs>
+            <a:gs pos="40000">
+              <a:schemeClr val="phClr">
+                <a:tint val="45000"/>
+                <a:shade val="99000"/>
+                <a:satMod val="350000"/>
+              </a:schemeClr>
+            </a:gs>
+            <a:gs pos="100000">
+              <a:schemeClr val="phClr">
+                <a:shade val="20000"/>
+                <a:satMod val="255000"/>
+              </a:schemeClr>
+            </a:gs>
+          </a:gsLst>
+          <a:path path="circle">
+            <a:fillToRect l="50000" t="-80000" r="50000" b="180000"/>
+          </a:path>
+        </a:gradFill>
+        <a:gradFill rotWithShape="1">
+          <a:gsLst>
+            <a:gs pos="0">
+              <a:schemeClr val="phClr">
+                <a:tint val="80000"/>
+                <a:satMod val="300000"/>
+              </a:schemeClr>
+            </a:gs>
+            <a:gs pos="100000">
+              <a:schemeClr val="phClr">
+                <a:shade val="30000"/>
+                <a:satMod val="200000"/>
+              </a:schemeClr>
+            </a:gs>
+          </a:gsLst>
+          <a:path path="circle">
+            <a:fillToRect l="50000" t="50000" r="50000" b="50000"/>
+          </a:path>
+        </a:gradFill>
+      </a:bgFillStyleLst>
+    </a:fmtScheme>
+  </a:themeElements>
+  <a:objectDefaults>
+    <a:spDef>
+      <a:spPr/>
+      <a:bodyPr/>
+      <a:lstStyle/>
+      <a:style>
+        <a:lnRef idx="1">
+          <a:schemeClr val="accent1"/>
+        </a:lnRef>
+        <a:fillRef idx="3">
+          <a:schemeClr val="accent1"/>
+        </a:fillRef>
+        <a:effectRef idx="2">
+          <a:schemeClr val="accent1"/>
+        </a:effectRef>
+        <a:fontRef idx="minor">
+          <a:schemeClr val="lt1"/>
+        </a:fontRef>
+      </a:style>
+    </a:spDef>
+    <a:lnDef>
+      <a:spPr/>
+      <a:bodyPr/>
+      <a:lstStyle/>
+      <a:style>
+        <a:lnRef idx="2">
+          <a:schemeClr val="accent1"/>
+        </a:lnRef>
+        <a:fillRef idx="0">
+          <a:schemeClr val="accent1"/>
+        </a:fillRef>
+        <a:effectRef idx="1">
+          <a:schemeClr val="accent1"/>
+        </a:effectRef>
+        <a:fontRef idx="minor">
+          <a:schemeClr val="tx1"/>
+        </a:fontRef>
+      </a:style>
+    </a:lnDef>
+  </a:objectDefaults>
+  <a:extraClrSchemeLst/>
+</a:theme>
 </file>
</xml_diff>